<commit_message>
docs: agrega la URL del repositorio en la presentación y el README
Co-Authored-By: Claude Opus 5 <noreply@anthropic.com>
</commit_message>
<xml_diff>
--- a/docs/GuardIA-ProyectoFinal-IdoyagaMolina.pptx
+++ b/docs/GuardIA-ProyectoFinal-IdoyagaMolina.pptx
@@ -9655,7 +9655,7 @@
                 <a:ea typeface="Courier New" pitchFamily="34" charset="-122"/>
                 <a:cs typeface="Courier New" pitchFamily="34" charset="-120"/>
               </a:rPr>
-              <a:t>https://github.com/usuario/guardia</a:t>
+              <a:t>https://github.com/cubi20/guardia</a:t>
             </a:r>
             <a:endParaRPr lang="en-US" sz="1100" dirty="0"/>
           </a:p>
@@ -9971,7 +9971,7 @@
                 <a:ea typeface="Calibri" pitchFamily="34" charset="-122"/>
                 <a:cs typeface="Calibri" pitchFamily="34" charset="-120"/>
               </a:rPr>
-              <a:t>Reemplazá las tres direcciones de arriba por los enlaces definitivos antes de entregar.</a:t>
+              <a:t>Falta reemplazar el enlace de Streamlit y el del video por los definitivos.</a:t>
             </a:r>
             <a:endParaRPr lang="en-US" sz="1050" dirty="0"/>
           </a:p>

</xml_diff>

<commit_message>
fix: un solo clic alcanza para analizar
Probando la app desplegada apareció un problema de uso serio: había que
apretar "Analizar mensaje" dos veces. Streamlit no confirma el contenido
de un text_area hasta que pierde el foco, así que el primer clic se
consumía en confirmar el texto y el segundo recién disparaba el análisis.
Quien escribía el mensaje y apretaba una vez recibía "Pegá el texto del
mensaje que querés analizar" con el campo lleno.

Los campos y el botón pasan a estar dentro de un st.form: el envío
confirma todos los valores y ejecuta el análisis en una sola acción. El
selector de ejemplos queda fuera del formulario porque necesita on_change.

Se agrega la URL de la aplicación desplegada al README y a la lámina 15.

Co-Authored-By: Claude Opus 5 <noreply@anthropic.com>
</commit_message>
<xml_diff>
--- a/docs/GuardIA-ProyectoFinal-IdoyagaMolina.pptx
+++ b/docs/GuardIA-ProyectoFinal-IdoyagaMolina.pptx
@@ -9378,7 +9378,7 @@
                 <a:ea typeface="Courier New" pitchFamily="34" charset="-122"/>
                 <a:cs typeface="Courier New" pitchFamily="34" charset="-120"/>
               </a:rPr>
-              <a:t>https://guardia.streamlit.app</a:t>
+              <a:t>guardia-iayvrupcyvzqzibgemf7l7.streamlit.app</a:t>
             </a:r>
             <a:endParaRPr lang="en-US" sz="1100" dirty="0"/>
           </a:p>
@@ -9971,7 +9971,7 @@
                 <a:ea typeface="Calibri" pitchFamily="34" charset="-122"/>
                 <a:cs typeface="Calibri" pitchFamily="34" charset="-120"/>
               </a:rPr>
-              <a:t>Falta reemplazar el enlace de Streamlit y el del video por los definitivos.</a:t>
+              <a:t>Falta reemplazar el enlace del video por el definitivo.</a:t>
             </a:r>
             <a:endParaRPr lang="en-US" sz="1050" dirty="0"/>
           </a:p>

</xml_diff>

<commit_message>
docs: unifica el nombre del curso con el de la plataforma
La consigna del Proyecto Final lo llama 'Prompt Engineering para
Programadores', que parece ser un nombre legado. En CoderHouse la
materia figura como 'Inteligencia artificial: Generación de Prompts',
comisión #95920, y ese es el nombre que ve quien corrige.

Co-Authored-By: Claude Opus 5 <noreply@anthropic.com>
</commit_message>
<xml_diff>
--- a/docs/GuardIA-ProyectoFinal-IdoyagaMolina.pptx
+++ b/docs/GuardIA-ProyectoFinal-IdoyagaMolina.pptx
@@ -2471,7 +2471,7 @@
                 <a:ea typeface="Calibri" pitchFamily="34" charset="-122"/>
                 <a:cs typeface="Calibri" pitchFamily="34" charset="-120"/>
               </a:rPr>
-              <a:t>PROYECTO FINAL   ·   PROMPT ENGINEERING PARA PROGRAMADORES</a:t>
+              <a:t>PROYECTO FINAL   ·   INTELIGENCIA ARTIFICIAL: GENERACIÓN DE PROMPTS</a:t>
             </a:r>
             <a:endParaRPr lang="en-US" sz="1200" dirty="0"/>
           </a:p>
@@ -2800,7 +2800,7 @@
                 <a:ea typeface="Calibri" pitchFamily="34" charset="-122"/>
                 <a:cs typeface="Calibri" pitchFamily="34" charset="-120"/>
               </a:rPr>
-              <a:t>Prompt Engineering para Programadores</a:t>
+              <a:t>Inteligencia artificial: Generación de Prompts</a:t>
             </a:r>
             <a:endParaRPr lang="en-US" sz="1600" dirty="0"/>
           </a:p>
@@ -3687,7 +3687,7 @@
                 <a:ea typeface="Calibri" pitchFamily="34" charset="-122"/>
                 <a:cs typeface="Calibri" pitchFamily="34" charset="-120"/>
               </a:rPr>
-              <a:t>  ·  Proyecto Final — Prompt Engineering para Programadores · CoderHouse</a:t>
+              <a:t>  ·  Proyecto Final — Inteligencia artificial: Generación de Prompts · CoderHouse</a:t>
             </a:r>
             <a:endParaRPr lang="en-US" sz="900" dirty="0"/>
           </a:p>
@@ -4760,7 +4760,7 @@
                 <a:ea typeface="Calibri" pitchFamily="34" charset="-122"/>
                 <a:cs typeface="Calibri" pitchFamily="34" charset="-120"/>
               </a:rPr>
-              <a:t>  ·  Proyecto Final — Prompt Engineering para Programadores · CoderHouse</a:t>
+              <a:t>  ·  Proyecto Final — Inteligencia artificial: Generación de Prompts · CoderHouse</a:t>
             </a:r>
             <a:endParaRPr lang="en-US" sz="900" dirty="0"/>
           </a:p>
@@ -6110,7 +6110,7 @@
                 <a:ea typeface="Calibri" pitchFamily="34" charset="-122"/>
                 <a:cs typeface="Calibri" pitchFamily="34" charset="-120"/>
               </a:rPr>
-              <a:t>  ·  Proyecto Final — Prompt Engineering para Programadores · CoderHouse</a:t>
+              <a:t>  ·  Proyecto Final — Inteligencia artificial: Generación de Prompts · CoderHouse</a:t>
             </a:r>
             <a:endParaRPr lang="en-US" sz="900" dirty="0"/>
           </a:p>
@@ -8062,7 +8062,7 @@
                 <a:ea typeface="Calibri" pitchFamily="34" charset="-122"/>
                 <a:cs typeface="Calibri" pitchFamily="34" charset="-120"/>
               </a:rPr>
-              <a:t>  ·  Proyecto Final — Prompt Engineering para Programadores · CoderHouse</a:t>
+              <a:t>  ·  Proyecto Final — Inteligencia artificial: Generación de Prompts · CoderHouse</a:t>
             </a:r>
             <a:endParaRPr lang="en-US" sz="900" dirty="0"/>
           </a:p>
@@ -8952,7 +8952,7 @@
                 <a:ea typeface="Calibri" pitchFamily="34" charset="-122"/>
                 <a:cs typeface="Calibri" pitchFamily="34" charset="-120"/>
               </a:rPr>
-              <a:t>  ·  Proyecto Final — Prompt Engineering para Programadores · CoderHouse</a:t>
+              <a:t>  ·  Proyecto Final — Inteligencia artificial: Generación de Prompts · CoderHouse</a:t>
             </a:r>
             <a:endParaRPr lang="en-US" sz="900" dirty="0"/>
           </a:p>
@@ -10024,7 +10024,7 @@
                 <a:ea typeface="Calibri" pitchFamily="34" charset="-122"/>
                 <a:cs typeface="Calibri" pitchFamily="34" charset="-120"/>
               </a:rPr>
-              <a:t>  ·  Proyecto Final — Prompt Engineering para Programadores · CoderHouse</a:t>
+              <a:t>  ·  Proyecto Final — Inteligencia artificial: Generación de Prompts · CoderHouse</a:t>
             </a:r>
             <a:endParaRPr lang="en-US" sz="900" dirty="0"/>
           </a:p>
@@ -10742,7 +10742,7 @@
                 <a:ea typeface="Calibri" pitchFamily="34" charset="-122"/>
                 <a:cs typeface="Calibri" pitchFamily="34" charset="-120"/>
               </a:rPr>
-              <a:t>  ·  Proyecto Final — Prompt Engineering para Programadores · CoderHouse</a:t>
+              <a:t>  ·  Proyecto Final — Inteligencia artificial: Generación de Prompts · CoderHouse</a:t>
             </a:r>
             <a:endParaRPr lang="en-US" sz="900" dirty="0"/>
           </a:p>
@@ -11694,7 +11694,7 @@
                 <a:ea typeface="Calibri" pitchFamily="34" charset="-122"/>
                 <a:cs typeface="Calibri" pitchFamily="34" charset="-120"/>
               </a:rPr>
-              <a:t>  ·  Proyecto Final — Prompt Engineering para Programadores · CoderHouse</a:t>
+              <a:t>  ·  Proyecto Final — Inteligencia artificial: Generación de Prompts · CoderHouse</a:t>
             </a:r>
             <a:endParaRPr lang="en-US" sz="900" dirty="0"/>
           </a:p>
@@ -12292,7 +12292,7 @@
                 <a:ea typeface="Calibri" pitchFamily="34" charset="-122"/>
                 <a:cs typeface="Calibri" pitchFamily="34" charset="-120"/>
               </a:rPr>
-              <a:t>  ·  Proyecto Final — Prompt Engineering para Programadores · CoderHouse</a:t>
+              <a:t>  ·  Proyecto Final — Inteligencia artificial: Generación de Prompts · CoderHouse</a:t>
             </a:r>
             <a:endParaRPr lang="en-US" sz="900" dirty="0"/>
           </a:p>
@@ -13010,7 +13010,7 @@
                 <a:ea typeface="Calibri" pitchFamily="34" charset="-122"/>
                 <a:cs typeface="Calibri" pitchFamily="34" charset="-120"/>
               </a:rPr>
-              <a:t>  ·  Proyecto Final — Prompt Engineering para Programadores · CoderHouse</a:t>
+              <a:t>  ·  Proyecto Final — Inteligencia artificial: Generación de Prompts · CoderHouse</a:t>
             </a:r>
             <a:endParaRPr lang="en-US" sz="900" dirty="0"/>
           </a:p>
@@ -13875,7 +13875,7 @@
                 <a:ea typeface="Calibri" pitchFamily="34" charset="-122"/>
                 <a:cs typeface="Calibri" pitchFamily="34" charset="-120"/>
               </a:rPr>
-              <a:t>  ·  Proyecto Final — Prompt Engineering para Programadores · CoderHouse</a:t>
+              <a:t>  ·  Proyecto Final — Inteligencia artificial: Generación de Prompts · CoderHouse</a:t>
             </a:r>
             <a:endParaRPr lang="en-US" sz="900" dirty="0"/>
           </a:p>
@@ -14665,7 +14665,7 @@
                 <a:ea typeface="Calibri" pitchFamily="34" charset="-122"/>
                 <a:cs typeface="Calibri" pitchFamily="34" charset="-120"/>
               </a:rPr>
-              <a:t>  ·  Proyecto Final — Prompt Engineering para Programadores · CoderHouse</a:t>
+              <a:t>  ·  Proyecto Final — Inteligencia artificial: Generación de Prompts · CoderHouse</a:t>
             </a:r>
             <a:endParaRPr lang="en-US" sz="900" dirty="0"/>
           </a:p>
@@ -15160,7 +15160,7 @@
                 <a:ea typeface="Calibri" pitchFamily="34" charset="-122"/>
                 <a:cs typeface="Calibri" pitchFamily="34" charset="-120"/>
               </a:rPr>
-              <a:t>  ·  Proyecto Final — Prompt Engineering para Programadores · CoderHouse</a:t>
+              <a:t>  ·  Proyecto Final — Inteligencia artificial: Generación de Prompts · CoderHouse</a:t>
             </a:r>
             <a:endParaRPr lang="en-US" sz="900" dirty="0"/>
           </a:p>
@@ -15966,7 +15966,7 @@
                 <a:ea typeface="Calibri" pitchFamily="34" charset="-122"/>
                 <a:cs typeface="Calibri" pitchFamily="34" charset="-120"/>
               </a:rPr>
-              <a:t>  ·  Proyecto Final — Prompt Engineering para Programadores · CoderHouse</a:t>
+              <a:t>  ·  Proyecto Final — Inteligencia artificial: Generación de Prompts · CoderHouse</a:t>
             </a:r>
             <a:endParaRPr lang="en-US" sz="900" dirty="0"/>
           </a:p>
@@ -17116,7 +17116,7 @@
                 <a:ea typeface="Calibri" pitchFamily="34" charset="-122"/>
                 <a:cs typeface="Calibri" pitchFamily="34" charset="-120"/>
               </a:rPr>
-              <a:t>  ·  Proyecto Final — Prompt Engineering para Programadores · CoderHouse</a:t>
+              <a:t>  ·  Proyecto Final — Inteligencia artificial: Generación de Prompts · CoderHouse</a:t>
             </a:r>
             <a:endParaRPr lang="en-US" sz="900" dirty="0"/>
           </a:p>

</xml_diff>